<commit_message>
docs(strategy): enrich slide 7 speaker notes with per-word reference
Each of the seven ICN spine words (Standing, Authority, Decision,
Obligation, Receipt, Evidence, Review) now has a definition, a "how it
works" line, and a quick-reference note in the speaker copy. The recite
script stays ≈40 seconds; the per-word block is reference material the
speaker only reaches for if McKenzie asks about a specific word.

Format per word:
- Definition (the one-sentence "what it is")
- How it works (the concrete mechanism — what makes it different from a
  Loomio vote, a Google Doc edit, or a spreadsheet entry)
- Quick (the boundary or the example the speaker reaches for in the
  moment)

Applied consistently to the pptx builder, the markdown source, and the
HTML deck. PDF regenerated.

🤖 Generated with [Claude Code](https://claude.com/claude-code)

Co-Authored-By: Claude Opus 4.7 <noreply@anthropic.com>
</commit_message>
<xml_diff>
--- a/docs/strategy/COOPERATIVE_FORMATION_PLATFORM_SCREEN_DECK_2026-05-21.pptx
+++ b/docs/strategy/COOPERATIVE_FORMATION_PLATFORM_SCREEN_DECK_2026-05-21.pptx
@@ -1256,12 +1256,33 @@
           <a:p>
             <a:r>
               <a:rPr lang="en-US" dirty="0"/>
-              <a:t>PURPOSE: compress ICN into seven words she can remember. ≈40 sec.
+              <a:t>PURPOSE: compress ICN into seven words she can remember. ≈40 sec to recite.
 Spoken copy:
 “If I had to compress ICN into seven words, it'd be these. [Read across the rows, one breath if you can:] Standing. Authority. Decision. Obligation. Receipt. Evidence. Review.”
 [Beat. Then the why.]
 “Not because every human process should become software. Because some records need to survive turnover, without everyone reconstructing the institution from email, PDFs, and somebody's exhausted memory.”
-[Move on unless she has a question. Do not pitch each word.]</a:t>
+[Move on unless she asks. Do not pitch each word. If she asks about any one of them, use these:]
+STANDING — who has the right to act in this context.
+  How it works: signed records of admission, transition, exit. Cryptographic proof of membership at a moment in time.
+  Quick: not membership management. Membership EVIDENCE. So a new treasurer in 2030 can answer who actually voted on this in 2027.
+AUTHORITY — who can authorize what, under what governance rule.
+  How it works: expressed in CCL (Cooperative Contract Language). The kernel enforces the constraint without understanding the meaning.
+  Quick: always reducible to a rule + a role + a threshold. Structural, not personal.
+DECISION — a choice made under authority, with threshold met.
+  How it works: links the proposal that triggered it, the votes cast, the threshold reached, the effect authorized.
+  Quick: a vote is not a decision until the threshold is met AND the result is recorded. The recording IS the decision.
+OBLIGATION — a commitment created by a decision.
+  How it works: obligor, obligee, scope, triggering decision, evidence-of-completion.
+  Quick: replaces 'debt' / 'liability' in ICN vocabulary. Advisor agreements, patronage allocations, federation commitments all live here.
+RECEIPT — a verifiable record that an event happened.
+  How it works: signed, content-addressed, everything attached; verifiable independently of any platform.
+  Quick: receipts alone do not prove legitimacy. They prove the event. Authority and review are separate.
+EVIDENCE — receipts plus context, available later.
+  How it works: receipts plus the chain (charter, governance rules, prior decisions) needed to interpret them; survives platform migration.
+  Quick: the difference between 'we had a vote' and 'we can verify the vote across years and platforms.'
+REVIEW — anyone can verify the chain.
+  How it works: cryptographic check of signatures + inspection of the contextual chain to confirm authority was real.
+  Quick: without review, receipts are files. With review, they are evidence. This is what makes ICN useful as institutional memory.</a:t>
             </a:r>
             <a:endParaRPr lang="en-US" dirty="0"/>
           </a:p>

</xml_diff>

<commit_message>
feat(dev-portal): add icn.zone scaffold and strategy packet
</commit_message>
<xml_diff>
--- a/docs/strategy/COOPERATIVE_FORMATION_PLATFORM_SCREEN_DECK_2026-05-21.pptx
+++ b/docs/strategy/COOPERATIVE_FORMATION_PLATFORM_SCREEN_DECK_2026-05-21.pptx
@@ -1256,9 +1256,9 @@
           <a:p>
             <a:r>
               <a:rPr lang="en-US" dirty="0"/>
-              <a:t>PURPOSE: compress ICN into seven words she can remember. ≈40 sec to recite.
+              <a:t>PURPOSE: compress ICN into eight words she can remember. ≈40 sec to recite. This is the canonical spine used across the repo (NYCN_SUMMIT_REFERENCE_INSTITUTION_STRATEGY, NYCN_ORGANIZER_MEETING_ONE_PAGE_AID, MCKENZIE_LIVE_NOTES).
 Spoken copy:
-“If I had to compress ICN into seven words, it'd be these. [Read across the rows, one breath if you can:] Standing. Authority. Decision. Obligation. Receipt. Evidence. Review.”
+“If I had to compress ICN into eight words, it'd be these. [Read across the rows, one breath if you can:] Standing. Authority. Decision. Obligation. Effect. Receipt. Evidence. Review.”
 [Beat. Then the why.]
 “Not because every human process should become software. Because some records need to survive turnover, without everyone reconstructing the institution from email, PDFs, and somebody's exhausted memory.”
 [Move on unless she asks. Do not pitch each word. If she asks about any one of them, use these:]
@@ -1274,6 +1274,9 @@
 OBLIGATION — a commitment created by a decision.
   How it works: obligor, obligee, scope, triggering decision, evidence-of-completion.
   Quick: replaces 'debt' / 'liability' in ICN vocabulary. Advisor agreements, patronage allocations, federation commitments all live here.
+EFFECT — the actual change in the world that a decision caused.
+  How it works: the state transition (a member is admitted, an allocation lands, a bylaw is adopted) that follows from authority + decision and produces the receipt.
+  Quick: a decision without an effect is just talk. The effect is what makes the receipt verifiable as a real institutional event.
 RECEIPT — a verifiable record that an event happened.
   How it works: signed, content-addressed, everything attached; verifiable independently of any platform.
   Quick: receipts alone do not prove legitimacy. They prove the event. Authority and review are separate.
@@ -4463,7 +4466,7 @@
                 <a:ea typeface="Calibri" pitchFamily="34" charset="-122"/>
                 <a:cs typeface="Calibri" pitchFamily="34" charset="-120"/>
               </a:rPr>
-              <a:t>Seven words. Not in this order in real life, but this is the shape.</a:t>
+              <a:t>Eight words. Not in this order in real life, but this is the shape.</a:t>
             </a:r>
             <a:endParaRPr lang="en-US" sz="1600" dirty="0"/>
           </a:p>
@@ -4742,7 +4745,7 @@
         <p:spPr>
           <a:xfrm>
             <a:off x="822960" y="3520440"/>
-            <a:ext cx="3362858" cy="914400"/>
+            <a:ext cx="2464994" cy="914400"/>
           </a:xfrm>
           <a:prstGeom prst="roundRect">
             <a:avLst>
@@ -4769,7 +4772,7 @@
         <p:spPr>
           <a:xfrm>
             <a:off x="822960" y="3520440"/>
-            <a:ext cx="3362858" cy="914400"/>
+            <a:ext cx="2464994" cy="914400"/>
           </a:xfrm>
           <a:prstGeom prst="rect">
             <a:avLst/>
@@ -4793,7 +4796,7 @@
                 <a:ea typeface="Calibri" pitchFamily="34" charset="-122"/>
                 <a:cs typeface="Calibri" pitchFamily="34" charset="-120"/>
               </a:rPr>
-              <a:t>Receipt.</a:t>
+              <a:t>Effect.</a:t>
             </a:r>
             <a:endParaRPr lang="en-US" sz="2200" dirty="0"/>
           </a:p>
@@ -4807,8 +4810,8 @@
         </p:nvSpPr>
         <p:spPr>
           <a:xfrm>
-            <a:off x="4414418" y="3520440"/>
-            <a:ext cx="3362858" cy="914400"/>
+            <a:off x="3516554" y="3520440"/>
+            <a:ext cx="2464994" cy="914400"/>
           </a:xfrm>
           <a:prstGeom prst="roundRect">
             <a:avLst>
@@ -4834,8 +4837,8 @@
         </p:nvSpPr>
         <p:spPr>
           <a:xfrm>
-            <a:off x="4414418" y="3520440"/>
-            <a:ext cx="3362858" cy="914400"/>
+            <a:off x="3516554" y="3520440"/>
+            <a:ext cx="2464994" cy="914400"/>
           </a:xfrm>
           <a:prstGeom prst="rect">
             <a:avLst/>
@@ -4859,7 +4862,7 @@
                 <a:ea typeface="Calibri" pitchFamily="34" charset="-122"/>
                 <a:cs typeface="Calibri" pitchFamily="34" charset="-120"/>
               </a:rPr>
-              <a:t>Evidence.</a:t>
+              <a:t>Receipt.</a:t>
             </a:r>
             <a:endParaRPr lang="en-US" sz="2200" dirty="0"/>
           </a:p>
@@ -4873,8 +4876,8 @@
         </p:nvSpPr>
         <p:spPr>
           <a:xfrm>
-            <a:off x="8005877" y="3520440"/>
-            <a:ext cx="3362858" cy="914400"/>
+            <a:off x="6210148" y="3520440"/>
+            <a:ext cx="2464994" cy="914400"/>
           </a:xfrm>
           <a:prstGeom prst="roundRect">
             <a:avLst>
@@ -4900,8 +4903,8 @@
         </p:nvSpPr>
         <p:spPr>
           <a:xfrm>
-            <a:off x="8005877" y="3520440"/>
-            <a:ext cx="3362858" cy="914400"/>
+            <a:off x="6210148" y="3520440"/>
+            <a:ext cx="2464994" cy="914400"/>
           </a:xfrm>
           <a:prstGeom prst="rect">
             <a:avLst/>
@@ -4925,6 +4928,72 @@
                 <a:ea typeface="Calibri" pitchFamily="34" charset="-122"/>
                 <a:cs typeface="Calibri" pitchFamily="34" charset="-120"/>
               </a:rPr>
+              <a:t>Evidence.</a:t>
+            </a:r>
+            <a:endParaRPr lang="en-US" sz="2200" dirty="0"/>
+          </a:p>
+        </p:txBody>
+      </p:sp>
+      <p:sp>
+        <p:nvSpPr>
+          <p:cNvPr id="21" name="Shape 19"/>
+          <p:cNvSpPr/>
+          <p:nvPr/>
+        </p:nvSpPr>
+        <p:spPr>
+          <a:xfrm>
+            <a:off x="8903741" y="3520440"/>
+            <a:ext cx="2464994" cy="914400"/>
+          </a:xfrm>
+          <a:prstGeom prst="roundRect">
+            <a:avLst>
+              <a:gd name="adj" fmla="val 8000"/>
+            </a:avLst>
+          </a:prstGeom>
+          <a:solidFill>
+            <a:srgbClr val="FFFFFF"/>
+          </a:solidFill>
+          <a:ln w="15875">
+            <a:solidFill>
+              <a:srgbClr val="1A1D21"/>
+            </a:solidFill>
+            <a:prstDash val="solid"/>
+          </a:ln>
+        </p:spPr>
+      </p:sp>
+      <p:sp>
+        <p:nvSpPr>
+          <p:cNvPr id="22" name="Text 20"/>
+          <p:cNvSpPr/>
+          <p:nvPr/>
+        </p:nvSpPr>
+        <p:spPr>
+          <a:xfrm>
+            <a:off x="8903741" y="3520440"/>
+            <a:ext cx="2464994" cy="914400"/>
+          </a:xfrm>
+          <a:prstGeom prst="rect">
+            <a:avLst/>
+          </a:prstGeom>
+          <a:noFill/>
+          <a:ln/>
+        </p:spPr>
+        <p:txBody>
+          <a:bodyPr wrap="square" rtlCol="0" anchor="ctr"/>
+          <a:lstStyle/>
+          <a:p>
+            <a:pPr algn="ctr" indent="0" marL="0">
+              <a:buNone/>
+            </a:pPr>
+            <a:r>
+              <a:rPr lang="en-US" sz="2200" b="1" dirty="0">
+                <a:solidFill>
+                  <a:srgbClr val="1A1D21"/>
+                </a:solidFill>
+                <a:latin typeface="Calibri" pitchFamily="34" charset="0"/>
+                <a:ea typeface="Calibri" pitchFamily="34" charset="-122"/>
+                <a:cs typeface="Calibri" pitchFamily="34" charset="-120"/>
+              </a:rPr>
               <a:t>Review.</a:t>
             </a:r>
             <a:endParaRPr lang="en-US" sz="2200" dirty="0"/>
@@ -4933,7 +5002,7 @@
       </p:sp>
       <p:sp>
         <p:nvSpPr>
-          <p:cNvPr id="21" name="Text 19"/>
+          <p:cNvPr id="23" name="Text 21"/>
           <p:cNvSpPr/>
           <p:nvPr/>
         </p:nvSpPr>

</xml_diff>